<commit_message>
Finalize pgvector presentation project
</commit_message>
<xml_diff>
--- a/slides/pgvector_presentation.pptx
+++ b/slides/pgvector_presentation.pptx
@@ -143,15 +143,6 @@
 </p188:authorLst>
 </file>
 
-<file path=ppt/revisionInfo.xml><?xml version="1.0" encoding="utf-8"?>
-<p1510:revInfo xmlns:a="http://schemas.openxmlformats.org/drawingml/2006/main" xmlns:r="http://schemas.openxmlformats.org/officeDocument/2006/relationships" xmlns:p1510="http://schemas.microsoft.com/office/powerpoint/2015/10/main">
-  <p1510:revLst>
-    <p1510:client id="{2ED72D61-3966-2398-B924-7860E9FA4D6B}" v="644" dt="2026-04-14T14:29:38.332"/>
-    <p1510:client id="{5D1B2667-0ADA-28A6-AC58-25B0B84380B9}" v="106" dt="2026-04-14T17:34:56.808"/>
-  </p1510:revLst>
-</p1510:revInfo>
-</file>
-
 <file path=ppt/handoutMasters/handoutMaster1.xml><?xml version="1.0" encoding="utf-8"?>
 <p:handoutMaster xmlns:a="http://schemas.openxmlformats.org/drawingml/2006/main" xmlns:r="http://schemas.openxmlformats.org/officeDocument/2006/relationships" xmlns:p="http://schemas.openxmlformats.org/presentationml/2006/main">
   <p:cSld>
@@ -246,7 +237,7 @@
           <a:p>
             <a:fld id="{FA2C14BC-9E0B-417D-A4B6-D3A52302FEC1}" type="datetimeFigureOut">
               <a:rPr lang="en-US" smtClean="0"/>
-              <a:t>4/14/2026</a:t>
+              <a:t>4/26/2026</a:t>
             </a:fld>
             <a:endParaRPr lang="en-US"/>
           </a:p>
@@ -439,7 +430,7 @@
           <a:p>
             <a:fld id="{5C7FB986-3F20-4AE6-9D44-118BB6C2AE02}" type="datetimeFigureOut">
               <a:rPr lang="en-US" smtClean="0"/>
-              <a:t>4/14/2026</a:t>
+              <a:t>4/26/2026</a:t>
             </a:fld>
             <a:endParaRPr lang="en-US"/>
           </a:p>
@@ -931,7 +922,7 @@
           <a:p>
             <a:fld id="{7DA2CEDE-2AB4-4FB8-9551-E0AA4222B1A3}" type="datetime1">
               <a:rPr lang="en-US" smtClean="0"/>
-              <a:t>4/14/2026</a:t>
+              <a:t>4/26/2026</a:t>
             </a:fld>
             <a:endParaRPr lang="en-US" dirty="0"/>
           </a:p>
@@ -1344,7 +1335,7 @@
           <a:p>
             <a:fld id="{7DA2CEDE-2AB4-4FB8-9551-E0AA4222B1A3}" type="datetime1">
               <a:rPr lang="en-US" smtClean="0"/>
-              <a:t>4/14/2026</a:t>
+              <a:t>4/26/2026</a:t>
             </a:fld>
             <a:endParaRPr lang="en-US"/>
           </a:p>
@@ -1816,7 +1807,7 @@
           <a:p>
             <a:fld id="{7DA2CEDE-2AB4-4FB8-9551-E0AA4222B1A3}" type="datetime1">
               <a:rPr lang="en-US" smtClean="0"/>
-              <a:t>4/14/2026</a:t>
+              <a:t>4/26/2026</a:t>
             </a:fld>
             <a:endParaRPr lang="en-US"/>
           </a:p>
@@ -2180,7 +2171,7 @@
           <a:p>
             <a:fld id="{7DA2CEDE-2AB4-4FB8-9551-E0AA4222B1A3}" type="datetime1">
               <a:rPr lang="en-US" smtClean="0"/>
-              <a:t>4/14/2026</a:t>
+              <a:t>4/26/2026</a:t>
             </a:fld>
             <a:endParaRPr lang="en-US"/>
           </a:p>
@@ -2607,7 +2598,7 @@
           <a:p>
             <a:fld id="{7DA2CEDE-2AB4-4FB8-9551-E0AA4222B1A3}" type="datetime1">
               <a:rPr lang="en-US" smtClean="0"/>
-              <a:t>4/14/2026</a:t>
+              <a:t>4/26/2026</a:t>
             </a:fld>
             <a:endParaRPr lang="en-US"/>
           </a:p>
@@ -3153,7 +3144,7 @@
           <a:p>
             <a:fld id="{C2A0816E-BD5C-478F-AB95-6BE098266DF3}" type="datetime1">
               <a:rPr lang="en-US" smtClean="0"/>
-              <a:t>4/14/2026</a:t>
+              <a:t>4/26/2026</a:t>
             </a:fld>
             <a:endParaRPr lang="en-US"/>
           </a:p>
@@ -3660,7 +3651,7 @@
           <a:p>
             <a:fld id="{75515BC3-2A9C-497B-B82C-246EEDDDF89C}" type="datetime1">
               <a:rPr lang="en-US" smtClean="0"/>
-              <a:t>4/14/2026</a:t>
+              <a:t>4/26/2026</a:t>
             </a:fld>
             <a:endParaRPr lang="en-US"/>
           </a:p>
@@ -4212,7 +4203,7 @@
           <a:p>
             <a:fld id="{5CDEAC1E-5504-4723-BE4B-1DE8B305AF62}" type="datetime1">
               <a:rPr lang="en-US" smtClean="0"/>
-              <a:t>4/14/2026</a:t>
+              <a:t>4/26/2026</a:t>
             </a:fld>
             <a:endParaRPr lang="en-US"/>
           </a:p>
@@ -4596,7 +4587,7 @@
           <a:p>
             <a:fld id="{8E6582D0-CC23-4B30-B5F7-0EC0E82226EA}" type="datetime1">
               <a:rPr lang="en-US" smtClean="0"/>
-              <a:t>4/14/2026</a:t>
+              <a:t>4/26/2026</a:t>
             </a:fld>
             <a:endParaRPr lang="en-US"/>
           </a:p>
@@ -5228,7 +5219,7 @@
           <a:p>
             <a:fld id="{7DA2CEDE-2AB4-4FB8-9551-E0AA4222B1A3}" type="datetime1">
               <a:rPr lang="en-US" smtClean="0"/>
-              <a:t>4/14/2026</a:t>
+              <a:t>4/26/2026</a:t>
             </a:fld>
             <a:endParaRPr lang="en-US"/>
           </a:p>
@@ -5468,7 +5459,7 @@
           <a:p>
             <a:fld id="{7DA2CEDE-2AB4-4FB8-9551-E0AA4222B1A3}" type="datetime1">
               <a:rPr lang="en-US" smtClean="0"/>
-              <a:t>4/14/2026</a:t>
+              <a:t>4/26/2026</a:t>
             </a:fld>
             <a:endParaRPr lang="en-US"/>
           </a:p>
@@ -5848,7 +5839,7 @@
           <a:p>
             <a:fld id="{80EE6BAA-0080-49BB-A5F6-D96B22DFE410}" type="datetime1">
               <a:rPr lang="en-US" smtClean="0"/>
-              <a:t>4/14/2026</a:t>
+              <a:t>4/26/2026</a:t>
             </a:fld>
             <a:endParaRPr lang="en-US"/>
           </a:p>
@@ -6265,7 +6256,7 @@
           <a:p>
             <a:fld id="{C3E08220-0958-4EB6-84AC-FBA5654D4035}" type="datetime1">
               <a:rPr lang="en-US" smtClean="0"/>
-              <a:t>4/14/2026</a:t>
+              <a:t>4/26/2026</a:t>
             </a:fld>
             <a:endParaRPr lang="en-US"/>
           </a:p>
@@ -6491,7 +6482,7 @@
           <a:p>
             <a:fld id="{38149B0F-FE5F-465D-BF44-EE1D3847CE00}" type="datetime1">
               <a:rPr lang="en-US" smtClean="0"/>
-              <a:t>4/14/2026</a:t>
+              <a:t>4/26/2026</a:t>
             </a:fld>
             <a:endParaRPr lang="en-US"/>
           </a:p>
@@ -6735,7 +6726,7 @@
           <a:p>
             <a:fld id="{37DA9862-2C49-41B4-AD0B-6F93BC6DDDF8}" type="datetime1">
               <a:rPr lang="en-US" smtClean="0"/>
-              <a:t>4/14/2026</a:t>
+              <a:t>4/26/2026</a:t>
             </a:fld>
             <a:endParaRPr lang="en-US"/>
           </a:p>
@@ -7114,7 +7105,7 @@
           <a:p>
             <a:fld id="{38149B0F-FE5F-465D-BF44-EE1D3847CE00}" type="datetime1">
               <a:rPr lang="en-US" smtClean="0"/>
-              <a:t>4/14/2026</a:t>
+              <a:t>4/26/2026</a:t>
             </a:fld>
             <a:endParaRPr lang="en-US"/>
           </a:p>
@@ -7353,7 +7344,7 @@
           <a:p>
             <a:fld id="{37D881E9-FF16-48A7-B8AA-A17AAAEAD6E1}" type="datetime1">
               <a:rPr lang="en-US" smtClean="0"/>
-              <a:t>4/14/2026</a:t>
+              <a:t>4/26/2026</a:t>
             </a:fld>
             <a:endParaRPr lang="en-US"/>
           </a:p>
@@ -7739,7 +7730,7 @@
           <a:p>
             <a:fld id="{52D95AE2-CFB9-4B68-957C-4721356B27A9}" type="datetime1">
               <a:rPr lang="en-US" smtClean="0"/>
-              <a:t>4/14/2026</a:t>
+              <a:t>4/26/2026</a:t>
             </a:fld>
             <a:endParaRPr lang="en-US"/>
           </a:p>
@@ -8166,7 +8157,7 @@
           <a:p>
             <a:fld id="{862C1B48-5712-40E8-928E-1136C5D12A17}" type="datetime1">
               <a:rPr lang="en-US" smtClean="0"/>
-              <a:t>4/14/2026</a:t>
+              <a:t>4/26/2026</a:t>
             </a:fld>
             <a:endParaRPr lang="en-US"/>
           </a:p>
@@ -8486,7 +8477,7 @@
           <a:p>
             <a:fld id="{2BDF39F2-6977-4B14-98E3-4DFE82804B0D}" type="datetime1">
               <a:rPr lang="en-US" smtClean="0"/>
-              <a:t>4/14/2026</a:t>
+              <a:t>4/26/2026</a:t>
             </a:fld>
             <a:endParaRPr lang="en-US"/>
           </a:p>
@@ -8901,7 +8892,7 @@
           <a:p>
             <a:fld id="{2BDF39F2-6977-4B14-98E3-4DFE82804B0D}" type="datetime1">
               <a:rPr lang="en-US" smtClean="0"/>
-              <a:t>4/14/2026</a:t>
+              <a:t>4/26/2026</a:t>
             </a:fld>
             <a:endParaRPr lang="en-US"/>
           </a:p>
@@ -9302,7 +9293,7 @@
           <a:p>
             <a:fld id="{862C1B48-5712-40E8-928E-1136C5D12A17}" type="datetime1">
               <a:rPr lang="en-US" smtClean="0"/>
-              <a:t>4/14/2026</a:t>
+              <a:t>4/26/2026</a:t>
             </a:fld>
             <a:endParaRPr lang="en-US"/>
           </a:p>
@@ -9735,7 +9726,7 @@
           <a:p>
             <a:fld id="{21560963-1EEA-4BDE-8FF9-3FEE13B5D43C}" type="datetime1">
               <a:rPr lang="en-US" smtClean="0"/>
-              <a:t>4/14/2026</a:t>
+              <a:t>4/26/2026</a:t>
             </a:fld>
             <a:endParaRPr lang="en-US"/>
           </a:p>
@@ -10052,7 +10043,7 @@
           <a:p>
             <a:fld id="{862C1B48-5712-40E8-928E-1136C5D12A17}" type="datetime1">
               <a:rPr lang="en-US" smtClean="0"/>
-              <a:t>4/14/2026</a:t>
+              <a:t>4/26/2026</a:t>
             </a:fld>
             <a:endParaRPr lang="en-US"/>
           </a:p>
@@ -10257,7 +10248,7 @@
           <a:p>
             <a:fld id="{323EC03A-74B3-46B6-A70D-0B367EABDC7F}" type="datetime1">
               <a:rPr lang="en-US" smtClean="0"/>
-              <a:t>4/14/2026</a:t>
+              <a:t>4/26/2026</a:t>
             </a:fld>
             <a:endParaRPr lang="en-US"/>
           </a:p>
@@ -10714,7 +10705,7 @@
           <a:p>
             <a:fld id="{D6F66A7C-2450-4D43-AEC7-53AFAE9E8A03}" type="datetime1">
               <a:rPr lang="en-US" smtClean="0"/>
-              <a:t>4/14/2026</a:t>
+              <a:t>4/26/2026</a:t>
             </a:fld>
             <a:endParaRPr lang="en-US"/>
           </a:p>
@@ -11211,7 +11202,7 @@
           <a:p>
             <a:fld id="{7DA2CEDE-2AB4-4FB8-9551-E0AA4222B1A3}" type="datetime1">
               <a:rPr lang="en-US" smtClean="0"/>
-              <a:t>4/14/2026</a:t>
+              <a:t>4/26/2026</a:t>
             </a:fld>
             <a:endParaRPr lang="en-US"/>
           </a:p>
@@ -11474,7 +11465,7 @@
           <a:p>
             <a:fld id="{323EC03A-74B3-46B6-A70D-0B367EABDC7F}" type="datetime1">
               <a:rPr lang="en-US" smtClean="0"/>
-              <a:t>4/14/2026</a:t>
+              <a:t>4/26/2026</a:t>
             </a:fld>
             <a:endParaRPr lang="en-US"/>
           </a:p>
@@ -11995,7 +11986,7 @@
           <a:p>
             <a:fld id="{FBC323F5-F813-45BA-B261-A7C41DB03AE5}" type="datetime1">
               <a:rPr lang="en-US" smtClean="0"/>
-              <a:t>4/14/2026</a:t>
+              <a:t>4/26/2026</a:t>
             </a:fld>
             <a:endParaRPr lang="en-US"/>
           </a:p>
@@ -12205,7 +12196,7 @@
           <a:p>
             <a:fld id="{7DA2CEDE-2AB4-4FB8-9551-E0AA4222B1A3}" type="datetime1">
               <a:rPr lang="en-US" smtClean="0"/>
-              <a:t>4/14/2026</a:t>
+              <a:t>4/26/2026</a:t>
             </a:fld>
             <a:endParaRPr lang="en-US"/>
           </a:p>
@@ -12613,7 +12604,7 @@
           <a:p>
             <a:fld id="{6D40D1C1-6E49-4083-B78C-1B50EA73104C}" type="datetime1">
               <a:rPr lang="en-US" smtClean="0"/>
-              <a:t>4/14/2026</a:t>
+              <a:t>4/26/2026</a:t>
             </a:fld>
             <a:endParaRPr lang="en-US"/>
           </a:p>
@@ -12975,7 +12966,7 @@
           <a:p>
             <a:fld id="{E74C9532-5249-4EF8-9302-9703A89C50A6}" type="datetime1">
               <a:rPr lang="en-US" smtClean="0"/>
-              <a:t>4/14/2026</a:t>
+              <a:t>4/26/2026</a:t>
             </a:fld>
             <a:endParaRPr lang="en-US"/>
           </a:p>
@@ -13247,7 +13238,7 @@
           <a:p>
             <a:fld id="{D4A97960-D10E-4C66-898F-E062784CD6C7}" type="datetime1">
               <a:rPr lang="en-US" smtClean="0"/>
-              <a:t>4/14/2026</a:t>
+              <a:t>4/26/2026</a:t>
             </a:fld>
             <a:endParaRPr lang="en-US"/>
           </a:p>
@@ -13867,7 +13858,7 @@
           <a:p>
             <a:fld id="{21560963-1EEA-4BDE-8FF9-3FEE13B5D43C}" type="datetime1">
               <a:rPr lang="en-US" smtClean="0"/>
-              <a:t>4/14/2026</a:t>
+              <a:t>4/26/2026</a:t>
             </a:fld>
             <a:endParaRPr lang="en-US"/>
           </a:p>
@@ -14047,7 +14038,7 @@
           <a:p>
             <a:fld id="{D4A97960-D10E-4C66-898F-E062784CD6C7}" type="datetime1">
               <a:rPr lang="en-US" smtClean="0"/>
-              <a:t>4/14/2026</a:t>
+              <a:t>4/26/2026</a:t>
             </a:fld>
             <a:endParaRPr lang="en-US"/>
           </a:p>
@@ -14338,7 +14329,7 @@
           <a:p>
             <a:fld id="{27B77AD4-7B4F-4A76-ADEB-9CF6601338DB}" type="datetime1">
               <a:rPr lang="en-US" smtClean="0"/>
-              <a:t>4/14/2026</a:t>
+              <a:t>4/26/2026</a:t>
             </a:fld>
             <a:endParaRPr lang="en-US"/>
           </a:p>
@@ -14604,7 +14595,7 @@
           <a:p>
             <a:fld id="{7E7D3A11-047C-4AE4-9A54-AA0426E18492}" type="datetime1">
               <a:rPr lang="en-US" smtClean="0"/>
-              <a:t>4/14/2026</a:t>
+              <a:t>4/26/2026</a:t>
             </a:fld>
             <a:endParaRPr lang="en-US"/>
           </a:p>
@@ -15198,7 +15189,7 @@
           <a:p>
             <a:fld id="{7DA2CEDE-2AB4-4FB8-9551-E0AA4222B1A3}" type="datetime1">
               <a:rPr lang="en-US" smtClean="0"/>
-              <a:t>4/14/2026</a:t>
+              <a:t>4/26/2026</a:t>
             </a:fld>
             <a:endParaRPr lang="en-US"/>
           </a:p>
@@ -15761,7 +15752,7 @@
           <a:p>
             <a:fld id="{7DA2CEDE-2AB4-4FB8-9551-E0AA4222B1A3}" type="datetime1">
               <a:rPr lang="en-US" smtClean="0"/>
-              <a:t>4/14/2026</a:t>
+              <a:t>4/26/2026</a:t>
             </a:fld>
             <a:endParaRPr lang="en-US"/>
           </a:p>
@@ -16271,7 +16262,7 @@
           <a:p>
             <a:fld id="{02E0CC3F-E257-4F6E-9E6A-B96D887699EC}" type="datetime1">
               <a:rPr lang="en-US" smtClean="0"/>
-              <a:t>4/14/2026</a:t>
+              <a:t>4/26/2026</a:t>
             </a:fld>
             <a:endParaRPr lang="en-US"/>
           </a:p>
@@ -16971,7 +16962,7 @@
           <a:p>
             <a:fld id="{BBFD9073-9E84-4C56-B5C8-FA6026186803}" type="datetime1">
               <a:rPr lang="en-US" smtClean="0"/>
-              <a:t>4/14/2026</a:t>
+              <a:t>4/26/2026</a:t>
             </a:fld>
             <a:endParaRPr lang="en-US"/>
           </a:p>
@@ -17306,7 +17297,7 @@
           <a:p>
             <a:fld id="{7FD71008-F1A2-4E65-9AFD-4970D8007661}" type="datetime1">
               <a:rPr lang="en-US" smtClean="0"/>
-              <a:t>4/14/2026</a:t>
+              <a:t>4/26/2026</a:t>
             </a:fld>
             <a:endParaRPr lang="en-US"/>
           </a:p>
@@ -17979,7 +17970,7 @@
           <a:p>
             <a:fld id="{35CFC7E7-57B7-4617-A947-41F006E88028}" type="datetime1">
               <a:rPr lang="en-US" smtClean="0"/>
-              <a:t>4/14/2026</a:t>
+              <a:t>4/26/2026</a:t>
             </a:fld>
             <a:endParaRPr lang="en-US"/>
           </a:p>
@@ -18750,7 +18741,7 @@
           <a:p>
             <a:fld id="{80BDAA3E-BE52-42BC-99E8-CCCB81A57ABD}" type="datetime1">
               <a:rPr lang="en-US" smtClean="0"/>
-              <a:t>4/14/2026</a:t>
+              <a:t>4/26/2026</a:t>
             </a:fld>
             <a:endParaRPr lang="en-US"/>
           </a:p>
@@ -19298,7 +19289,7 @@
           <a:p>
             <a:fld id="{BCA7961A-B010-49E0-A3F6-1ED7ACF29013}" type="datetime1">
               <a:rPr lang="en-US" smtClean="0"/>
-              <a:t>4/14/2026</a:t>
+              <a:t>4/26/2026</a:t>
             </a:fld>
             <a:endParaRPr lang="en-US"/>
           </a:p>
@@ -19707,7 +19698,7 @@
           <a:p>
             <a:fld id="{54A4A468-500F-41B2-B72F-78A325FCC0DA}" type="datetime1">
               <a:rPr lang="en-US" smtClean="0"/>
-              <a:t>4/14/2026</a:t>
+              <a:t>4/26/2026</a:t>
             </a:fld>
             <a:endParaRPr lang="en-US"/>
           </a:p>
@@ -20176,7 +20167,7 @@
           <a:p>
             <a:fld id="{7DA2CEDE-2AB4-4FB8-9551-E0AA4222B1A3}" type="datetime1">
               <a:rPr lang="en-US" smtClean="0"/>
-              <a:t>4/14/2026</a:t>
+              <a:t>4/26/2026</a:t>
             </a:fld>
             <a:endParaRPr lang="en-US"/>
           </a:p>
@@ -20456,7 +20447,7 @@
           <a:p>
             <a:fld id="{1B1491A9-BF26-4517-AB22-6183D453A902}" type="datetime1">
               <a:rPr lang="en-US" smtClean="0"/>
-              <a:t>4/14/2026</a:t>
+              <a:t>4/26/2026</a:t>
             </a:fld>
             <a:endParaRPr lang="en-US"/>
           </a:p>
@@ -21014,7 +21005,7 @@
           <a:p>
             <a:fld id="{3A5024DF-23AF-419A-978A-28215FBF1E37}" type="datetime1">
               <a:rPr lang="en-US" smtClean="0"/>
-              <a:t>4/14/2026</a:t>
+              <a:t>4/26/2026</a:t>
             </a:fld>
             <a:endParaRPr lang="en-US"/>
           </a:p>
@@ -21258,7 +21249,7 @@
           <a:p>
             <a:fld id="{9CF24436-170D-487D-ADBB-C24D74D1C150}" type="datetime1">
               <a:rPr lang="en-US" smtClean="0"/>
-              <a:t>4/14/2026</a:t>
+              <a:t>4/26/2026</a:t>
             </a:fld>
             <a:endParaRPr lang="en-US"/>
           </a:p>
@@ -21624,7 +21615,7 @@
           <a:p>
             <a:fld id="{7B01CFC0-D171-4F9D-A610-2F47C1080058}" type="datetime1">
               <a:rPr lang="en-US" smtClean="0"/>
-              <a:t>4/14/2026</a:t>
+              <a:t>4/26/2026</a:t>
             </a:fld>
             <a:endParaRPr lang="en-US"/>
           </a:p>
@@ -22016,7 +22007,7 @@
           <a:p>
             <a:fld id="{7DA2CEDE-2AB4-4FB8-9551-E0AA4222B1A3}" type="datetime1">
               <a:rPr lang="en-US" smtClean="0"/>
-              <a:t>4/14/2026</a:t>
+              <a:t>4/26/2026</a:t>
             </a:fld>
             <a:endParaRPr lang="en-US"/>
           </a:p>
@@ -22553,7 +22544,7 @@
           <a:p>
             <a:fld id="{16C42483-B3E3-4399-B6B2-4B1D067F8CE5}" type="datetime1">
               <a:rPr lang="en-US" smtClean="0"/>
-              <a:t>4/14/2026</a:t>
+              <a:t>4/26/2026</a:t>
             </a:fld>
             <a:endParaRPr lang="en-US"/>
           </a:p>
@@ -22669,7 +22660,7 @@
           <a:p>
             <a:fld id="{9A36574F-2CAD-411B-9EF3-12D0DF2C09EB}" type="datetime1">
               <a:rPr lang="en-US" smtClean="0"/>
-              <a:t>4/14/2026</a:t>
+              <a:t>4/26/2026</a:t>
             </a:fld>
             <a:endParaRPr lang="en-US"/>
           </a:p>
@@ -22824,7 +22815,7 @@
           <a:p>
             <a:fld id="{5B5223AD-184F-4273-AC4F-854D3B259B85}" type="datetime1">
               <a:rPr lang="en-US" smtClean="0"/>
-              <a:t>4/14/2026</a:t>
+              <a:t>4/26/2026</a:t>
             </a:fld>
             <a:endParaRPr lang="en-US"/>
           </a:p>
@@ -23580,7 +23571,7 @@
           <a:p>
             <a:fld id="{9458DF63-6CB9-404F-8464-DF813E7A7B12}" type="datetime1">
               <a:rPr lang="en-US" smtClean="0"/>
-              <a:t>4/14/2026</a:t>
+              <a:t>4/26/2026</a:t>
             </a:fld>
             <a:endParaRPr lang="en-US"/>
           </a:p>
@@ -23819,7 +23810,7 @@
           <a:p>
             <a:fld id="{907E4E07-E412-47A0-AB1E-CAAABECD1A31}" type="datetime1">
               <a:rPr lang="en-US" smtClean="0"/>
-              <a:t>4/14/2026</a:t>
+              <a:t>4/26/2026</a:t>
             </a:fld>
             <a:endParaRPr lang="en-US"/>
           </a:p>
@@ -24319,7 +24310,7 @@
           <a:p>
             <a:fld id="{21560963-1EEA-4BDE-8FF9-3FEE13B5D43C}" type="datetime1">
               <a:rPr lang="en-US" smtClean="0"/>
-              <a:t>4/14/2026</a:t>
+              <a:t>4/26/2026</a:t>
             </a:fld>
             <a:endParaRPr lang="en-US"/>
           </a:p>
@@ -24813,7 +24804,7 @@
           <a:p>
             <a:fld id="{082FB242-E4A2-4711-B168-6D02C45DBE61}" type="datetime1">
               <a:rPr lang="en-US" smtClean="0"/>
-              <a:t>4/14/2026</a:t>
+              <a:t>4/26/2026</a:t>
             </a:fld>
             <a:endParaRPr lang="en-US"/>
           </a:p>
@@ -25051,7 +25042,7 @@
           <a:p>
             <a:fld id="{7DA2CEDE-2AB4-4FB8-9551-E0AA4222B1A3}" type="datetime1">
               <a:rPr lang="en-US" smtClean="0"/>
-              <a:t>4/14/2026</a:t>
+              <a:t>4/26/2026</a:t>
             </a:fld>
             <a:endParaRPr lang="en-US"/>
           </a:p>
@@ -25373,7 +25364,7 @@
             <a:fld id="{7DA2CEDE-2AB4-4FB8-9551-E0AA4222B1A3}" type="datetime1">
               <a:rPr lang="en-US" smtClean="0"/>
               <a:pPr/>
-              <a:t>4/14/2026</a:t>
+              <a:t>4/26/2026</a:t>
             </a:fld>
             <a:endParaRPr lang="en-US" dirty="0"/>
           </a:p>

</xml_diff>